<commit_message>
add business meta-model svg download
</commit_message>
<xml_diff>
--- a/Master_EAS_Meta-Model.pptx
+++ b/Master_EAS_Meta-Model.pptx
@@ -10557,6 +10557,86 @@
           </a:p>
         </p:txBody>
       </p:sp>
+      <p:pic>
+        <p:nvPicPr>
+          <p:cNvPr id="9" name="Picture 8">
+            <a:extLst>
+              <a:ext uri="{FF2B5EF4-FFF2-40B4-BE49-F238E27FC236}">
+                <a16:creationId xmlns:a16="http://schemas.microsoft.com/office/drawing/2014/main" id="{9D7E3673-4348-0701-8D66-FB5EB7BAA58F}"/>
+              </a:ext>
+            </a:extLst>
+          </p:cNvPr>
+          <p:cNvPicPr>
+            <a:picLocks noChangeAspect="1"/>
+          </p:cNvPicPr>
+          <p:nvPr/>
+        </p:nvPicPr>
+        <p:blipFill>
+          <a:blip r:embed="rId3"/>
+          <a:stretch>
+            <a:fillRect/>
+          </a:stretch>
+        </p:blipFill>
+        <p:spPr>
+          <a:xfrm>
+            <a:off x="157000" y="1094226"/>
+            <a:ext cx="362976" cy="362976"/>
+          </a:xfrm>
+          <a:prstGeom prst="rect">
+            <a:avLst/>
+          </a:prstGeom>
+          <a:ln>
+            <a:noFill/>
+          </a:ln>
+          <a:effectLst>
+            <a:outerShdw blurRad="292100" dist="139700" dir="2700000" algn="tl" rotWithShape="0">
+              <a:srgbClr val="333333">
+                <a:alpha val="65000"/>
+              </a:srgbClr>
+            </a:outerShdw>
+          </a:effectLst>
+        </p:spPr>
+      </p:pic>
+      <p:pic>
+        <p:nvPicPr>
+          <p:cNvPr id="11" name="Picture 10">
+            <a:extLst>
+              <a:ext uri="{FF2B5EF4-FFF2-40B4-BE49-F238E27FC236}">
+                <a16:creationId xmlns:a16="http://schemas.microsoft.com/office/drawing/2014/main" id="{6CBDB4F7-AD96-E5FF-FB74-1EF32F3CFFC0}"/>
+              </a:ext>
+            </a:extLst>
+          </p:cNvPr>
+          <p:cNvPicPr>
+            <a:picLocks noChangeAspect="1"/>
+          </p:cNvPicPr>
+          <p:nvPr/>
+        </p:nvPicPr>
+        <p:blipFill>
+          <a:blip r:embed="rId4"/>
+          <a:stretch>
+            <a:fillRect/>
+          </a:stretch>
+        </p:blipFill>
+        <p:spPr>
+          <a:xfrm>
+            <a:off x="592618" y="1094226"/>
+            <a:ext cx="362976" cy="362976"/>
+          </a:xfrm>
+          <a:prstGeom prst="rect">
+            <a:avLst/>
+          </a:prstGeom>
+          <a:ln>
+            <a:noFill/>
+          </a:ln>
+          <a:effectLst>
+            <a:outerShdw blurRad="292100" dist="139700" dir="2700000" algn="tl" rotWithShape="0">
+              <a:srgbClr val="333333">
+                <a:alpha val="65000"/>
+              </a:srgbClr>
+            </a:outerShdw>
+          </a:effectLst>
+        </p:spPr>
+      </p:pic>
     </p:spTree>
     <p:extLst>
       <p:ext uri="{BB962C8B-B14F-4D97-AF65-F5344CB8AC3E}">
@@ -10852,6 +10932,46 @@
           </a:p>
         </p:txBody>
       </p:sp>
+      <p:pic>
+        <p:nvPicPr>
+          <p:cNvPr id="12" name="Picture 11">
+            <a:extLst>
+              <a:ext uri="{FF2B5EF4-FFF2-40B4-BE49-F238E27FC236}">
+                <a16:creationId xmlns:a16="http://schemas.microsoft.com/office/drawing/2014/main" id="{6B53E160-0729-9BA3-0260-559EB5A688A4}"/>
+              </a:ext>
+            </a:extLst>
+          </p:cNvPr>
+          <p:cNvPicPr>
+            <a:picLocks noChangeAspect="1"/>
+          </p:cNvPicPr>
+          <p:nvPr/>
+        </p:nvPicPr>
+        <p:blipFill>
+          <a:blip r:embed="rId3"/>
+          <a:stretch>
+            <a:fillRect/>
+          </a:stretch>
+        </p:blipFill>
+        <p:spPr>
+          <a:xfrm>
+            <a:off x="179657" y="1094226"/>
+            <a:ext cx="371111" cy="362976"/>
+          </a:xfrm>
+          <a:prstGeom prst="rect">
+            <a:avLst/>
+          </a:prstGeom>
+          <a:ln>
+            <a:noFill/>
+          </a:ln>
+          <a:effectLst>
+            <a:outerShdw blurRad="292100" dist="139700" dir="2700000" algn="tl" rotWithShape="0">
+              <a:srgbClr val="333333">
+                <a:alpha val="65000"/>
+              </a:srgbClr>
+            </a:outerShdw>
+          </a:effectLst>
+        </p:spPr>
+      </p:pic>
     </p:spTree>
     <p:extLst>
       <p:ext uri="{BB962C8B-B14F-4D97-AF65-F5344CB8AC3E}">

</xml_diff>